<commit_message>
Embed live VoiceBill web app screenshot into Slide 7 of presentation deck
</commit_message>
<xml_diff>
--- a/VoiceBill_HackSynthesis_Presentation.pptx
+++ b/VoiceBill_HackSynthesis_Presentation.pptx
@@ -6362,7 +6362,7 @@
         <p:spPr>
           <a:xfrm>
             <a:off x="731520" y="1645920"/>
-            <a:ext cx="10698480" cy="4114800"/>
+            <a:ext cx="5120640" cy="4297680"/>
           </a:xfrm>
           <a:prstGeom prst="roundRect">
             <a:avLst/>
@@ -6391,11 +6391,11 @@
           </a:fontRef>
         </p:style>
         <p:txBody>
-          <a:bodyPr rtlCol="0" anchor="ctr" wrap="square" lIns="365760" tIns="365760"/>
+          <a:bodyPr rtlCol="0" anchor="ctr" wrap="square" lIns="274320" tIns="274320"/>
           <a:lstStyle/>
           <a:p>
             <a:pPr algn="ctr">
-              <a:defRPr b="1" sz="1600">
+              <a:defRPr b="1" sz="1500">
                 <a:solidFill>
                   <a:srgbClr val="FFB703"/>
                 </a:solidFill>
@@ -6403,6 +6403,21 @@
             </a:pPr>
             <a:r>
               <a:t>🌐 LIVE GITHUB PAGES DEPLOYMENT</a:t>
+            </a:r>
+          </a:p>
+          <a:p>
+            <a:pPr>
+              <a:spcBef>
+                <a:spcPts val="800"/>
+              </a:spcBef>
+              <a:defRPr b="1" sz="1900">
+                <a:solidFill>
+                  <a:srgbClr val="FFFFFF"/>
+                </a:solidFill>
+              </a:defRPr>
+            </a:pPr>
+            <a:r>
+              <a:t>https://debajoyatibera.github.io/voicebill/</a:t>
             </a:r>
           </a:p>
           <a:p>
@@ -6410,14 +6425,14 @@
               <a:spcBef>
                 <a:spcPts val="1000"/>
               </a:spcBef>
-              <a:defRPr b="1" sz="3200">
-                <a:solidFill>
-                  <a:srgbClr val="FFFFFF"/>
-                </a:solidFill>
-              </a:defRPr>
-            </a:pPr>
-            <a:r>
-              <a:t>https://debajoyatibera.github.io/voicebill/</a:t>
+              <a:defRPr sz="1400">
+                <a:solidFill>
+                  <a:srgbClr val="94A3B8"/>
+                </a:solidFill>
+              </a:defRPr>
+            </a:pPr>
+            <a:r>
+              <a:t>We believe in true Open Innovation — our application is fully deployed, tested, and accessible to any judge or street vendor instantly on their browser.</a:t>
             </a:r>
           </a:p>
           <a:p>
@@ -6425,22 +6440,7 @@
               <a:spcBef>
                 <a:spcPts val="1400"/>
               </a:spcBef>
-              <a:defRPr sz="1600">
-                <a:solidFill>
-                  <a:srgbClr val="94A3B8"/>
-                </a:solidFill>
-              </a:defRPr>
-            </a:pPr>
-            <a:r>
-              <a:t>We believe in true Open Innovation — our application is fully deployed, tested, and accessible to any judge or street vendor instantly on their smartphone or laptop browser.</a:t>
-            </a:r>
-          </a:p>
-          <a:p>
-            <a:pPr>
-              <a:spcBef>
-                <a:spcPts val="2000"/>
-              </a:spcBef>
-              <a:defRPr sz="1600">
+              <a:defRPr sz="1400">
                 <a:solidFill>
                   <a:srgbClr val="00F5D4"/>
                 </a:solidFill>
@@ -6451,19 +6451,88 @@
             </a:r>
             <a:br/>
             <a:r>
-              <a:t>1. Open link &amp; tap the Glowing Mic button at the bottom center.</a:t>
+              <a:t>1. Open link &amp; tap the Glowing Mic button.</a:t>
             </a:r>
             <a:br/>
             <a:r>
-              <a:t>2. Speak: "do chai, panch panch rupaye" -&gt; see instant AI card creation &amp; hear rupee readback!</a:t>
+              <a:t>2. Speak: "do chai, panch panch rupaye" -&gt; see instant AI card &amp; hear rupee readback!</a:t>
             </a:r>
             <a:br/>
             <a:r>
-              <a:t>3. Tap the green "WhatsApp" button -&gt; see daily sales tally open synchronously in WhatsApp!</a:t>
-            </a:r>
-          </a:p>
-        </p:txBody>
-      </p:sp>
+              <a:t>3. Tap green "WhatsApp" button -&gt; see daily sales tally open synchronously!</a:t>
+            </a:r>
+          </a:p>
+        </p:txBody>
+      </p:sp>
+      <p:sp>
+        <p:nvSpPr>
+          <p:cNvPr id="6" name="Rounded Rectangle 5"/>
+          <p:cNvSpPr/>
+          <p:nvPr/>
+        </p:nvSpPr>
+        <p:spPr>
+          <a:xfrm>
+            <a:off x="6035040" y="1645920"/>
+            <a:ext cx="5394960" cy="4297680"/>
+          </a:xfrm>
+          <a:prstGeom prst="roundRect">
+            <a:avLst/>
+          </a:prstGeom>
+          <a:solidFill>
+            <a:srgbClr val="1C2541"/>
+          </a:solidFill>
+          <a:ln w="19050">
+            <a:solidFill>
+              <a:srgbClr val="00B4D8"/>
+            </a:solidFill>
+          </a:ln>
+        </p:spPr>
+        <p:style>
+          <a:lnRef idx="1">
+            <a:schemeClr val="accent1"/>
+          </a:lnRef>
+          <a:fillRef idx="3">
+            <a:schemeClr val="accent1"/>
+          </a:fillRef>
+          <a:effectRef idx="2">
+            <a:schemeClr val="accent1"/>
+          </a:effectRef>
+          <a:fontRef idx="minor">
+            <a:schemeClr val="lt1"/>
+          </a:fontRef>
+        </p:style>
+        <p:txBody>
+          <a:bodyPr rtlCol="0" anchor="ctr"/>
+          <a:lstStyle/>
+          <a:p>
+            <a:pPr algn="ctr"/>
+          </a:p>
+        </p:txBody>
+      </p:sp>
+      <p:pic>
+        <p:nvPicPr>
+          <p:cNvPr id="7" name="Picture 6" descr="screenshot_demo.png"/>
+          <p:cNvPicPr>
+            <a:picLocks noChangeAspect="1"/>
+          </p:cNvPicPr>
+          <p:nvPr/>
+        </p:nvPicPr>
+        <p:blipFill>
+          <a:blip r:embed="rId2"/>
+          <a:stretch>
+            <a:fillRect/>
+          </a:stretch>
+        </p:blipFill>
+        <p:spPr>
+          <a:xfrm>
+            <a:off x="6217920" y="1920240"/>
+            <a:ext cx="5029200" cy="2165896"/>
+          </a:xfrm>
+          <a:prstGeom prst="rect">
+            <a:avLst/>
+          </a:prstGeom>
+        </p:spPr>
+      </p:pic>
     </p:spTree>
   </p:cSld>
   <p:clrMapOvr>

</xml_diff>

<commit_message>
Make VoiceBill live demo URLs clickable in presentation deck
</commit_message>
<xml_diff>
--- a/VoiceBill_HackSynthesis_Presentation.pptx
+++ b/VoiceBill_HackSynthesis_Presentation.pptx
@@ -3370,13 +3370,14 @@
               <a:spcBef>
                 <a:spcPts val="1200"/>
               </a:spcBef>
-              <a:defRPr b="1" sz="1700">
-                <a:solidFill>
-                  <a:srgbClr val="FFFFFF"/>
-                </a:solidFill>
-              </a:defRPr>
-            </a:pPr>
-            <a:r>
+            </a:pPr>
+            <a:r>
+              <a:rPr b="1" sz="1700">
+                <a:solidFill>
+                  <a:srgbClr val="00F5D4"/>
+                </a:solidFill>
+                <a:hlinkClick r:id="rId2"/>
+              </a:rPr>
               <a:t>https://debajoyatibera.github.io/voicebill/</a:t>
             </a:r>
           </a:p>
@@ -6410,13 +6411,14 @@
               <a:spcBef>
                 <a:spcPts val="800"/>
               </a:spcBef>
-              <a:defRPr b="1" sz="1900">
-                <a:solidFill>
-                  <a:srgbClr val="FFFFFF"/>
-                </a:solidFill>
-              </a:defRPr>
-            </a:pPr>
-            <a:r>
+            </a:pPr>
+            <a:r>
+              <a:rPr b="1" sz="1900">
+                <a:solidFill>
+                  <a:srgbClr val="00F5D4"/>
+                </a:solidFill>
+                <a:hlinkClick r:id="rId2"/>
+              </a:rPr>
               <a:t>https://debajoyatibera.github.io/voicebill/</a:t>
             </a:r>
           </a:p>
@@ -6518,7 +6520,7 @@
           <p:nvPr/>
         </p:nvPicPr>
         <p:blipFill>
-          <a:blip r:embed="rId2"/>
+          <a:blip r:embed="rId3"/>
           <a:stretch>
             <a:fillRect/>
           </a:stretch>

</xml_diff>